<commit_message>
docs(decks): strip LedgeRX brand — UAF Reward System target architecture only
</commit_message>
<xml_diff>
--- a/docs/decks/LedgeRX-System-Architecture-CTO-Systems.pptx
+++ b/docs/decks/LedgeRX-System-Architecture-CTO-Systems.pptx
@@ -3208,7 +3208,7 @@
         <p:spPr>
           <a:xfrm>
             <a:off x="1691640" y="146304"/>
-            <a:ext cx="7772400" cy="256032"/>
+            <a:ext cx="8229600" cy="256032"/>
           </a:xfrm>
           <a:prstGeom prst="rect">
             <a:avLst/>
@@ -3243,7 +3243,7 @@
         <p:spPr>
           <a:xfrm>
             <a:off x="1691640" y="420624"/>
-            <a:ext cx="7772400" cy="201168"/>
+            <a:ext cx="8229600" cy="201168"/>
           </a:xfrm>
           <a:prstGeom prst="rect">
             <a:avLst/>
@@ -3264,7 +3264,7 @@
                 </a:solidFill>
                 <a:latin typeface="Calibri"/>
               </a:rPr>
-              <a:t>UAF builds the platform  ·  clear domain boundaries  ·  specialized ledger capability in the middle</a:t>
+              <a:t>UAF builds the platform  ·  clear domain boundaries  ·  Reward System as the core domain capability</a:t>
             </a:r>
           </a:p>
         </p:txBody>
@@ -3405,7 +3405,7 @@
                 </a:solidFill>
                 <a:latin typeface="Calibri"/>
               </a:rPr>
-              <a:t>Design principle: separate channel systems · integration fabric · reward ledger capability · UAF orchestration · fulfillment systems</a:t>
+              <a:t>Design principle: channel systems · integration fabric · Reward System · UAF orchestration · fulfillment systems</a:t>
             </a:r>
           </a:p>
         </p:txBody>
@@ -3856,7 +3856,7 @@
                 </a:solidFill>
                 <a:latin typeface="Calibri"/>
               </a:rPr>
-              <a:t>C  Reward ledger capability</a:t>
+              <a:t>C  Reward System</a:t>
             </a:r>
           </a:p>
         </p:txBody>
@@ -5504,7 +5504,7 @@
                 </a:solidFill>
                 <a:latin typeface="Calibri"/>
               </a:rPr>
-              <a:t>LedgeRX capability  =  Reward System</a:t>
+              <a:t>Central rewards domain</a:t>
             </a:r>
           </a:p>
         </p:txBody>
@@ -6270,7 +6270,7 @@
                 <a:latin typeface="Calibri"/>
               </a:rPr>
               <a:t>Ops-owned configuration (rules, COA, catalog).
-Channel teams call use-cases — they do not re-implement ledger math.</a:t>
+Channel teams call use-cases — they do not re-implement scoring math.</a:t>
             </a:r>
           </a:p>
         </p:txBody>
@@ -7072,8 +7072,8 @@
                 </a:solidFill>
                 <a:latin typeface="Calibri"/>
               </a:rPr>
-              <a:t>CTO narrative: We are standing up a modern rewards domain with clean boundaries — channels stay thin, ledger capability is centralized, fulfillment remains ours.
-This is UAF platform architecture — not a vendor black box dropped in the middle.</a:t>
+              <a:t>CTO narrative: We are standing up a modern rewards domain with clean boundaries — channels stay thin, Reward System is centralized, fulfillment remains ours.
+This is UAF platform architecture — a domain we own and operate.</a:t>
             </a:r>
           </a:p>
         </p:txBody>
@@ -7271,7 +7271,7 @@
                 </a:solidFill>
                 <a:latin typeface="Calibri"/>
               </a:rPr>
-              <a:t>One UAF-built hub is the only counterpart to the reward ledger  ·  everything else is our internal topology</a:t>
+              <a:t>One UAF-built hub is the only counterpart to Reward System  ·  everything else is our internal topology</a:t>
             </a:r>
           </a:p>
         </p:txBody>
@@ -7435,7 +7435,7 @@
                 </a:solidFill>
                 <a:latin typeface="Calibri"/>
               </a:rPr>
-              <a:t>CAPABILITY WE STAND UP</a:t>
+              <a:t>DOMAIN WE STAND UP</a:t>
             </a:r>
           </a:p>
         </p:txBody>
@@ -7470,7 +7470,7 @@
                 </a:solidFill>
                 <a:latin typeface="Calibri"/>
               </a:rPr>
-              <a:t>Reward ledger capability (LedgeRX)  =  UA Reward System</a:t>
+              <a:t>Reward System  ·  wallets, posting, calculation, books</a:t>
             </a:r>
           </a:p>
         </p:txBody>
@@ -7807,7 +7807,7 @@
                 </a:solidFill>
                 <a:latin typeface="Calibri"/>
               </a:rPr>
-              <a:t>Single integration surface to the reward ledger. UAF policy, routing, and business decisions live here.</a:t>
+              <a:t>Single integration surface to Reward System. UAF policy, routing, and business decisions live here.</a:t>
             </a:r>
           </a:p>
         </p:txBody>
@@ -7959,7 +7959,7 @@
                 </a:solidFill>
                 <a:latin typeface="Calibri"/>
               </a:rPr>
-              <a:t>Consume ledger outcomes (bus / API)</a:t>
+              <a:t>Consume Reward System outcomes (bus / API)</a:t>
             </a:r>
           </a:p>
         </p:txBody>
@@ -8470,7 +8470,7 @@
                 </a:solidFill>
                 <a:latin typeface="Calibri"/>
               </a:rPr>
-              <a:t>UAF internal topology — not exposed as ledger integration surfaces</a:t>
+              <a:t>UAF internal topology — not exposed as Reward System integration surfaces</a:t>
             </a:r>
           </a:p>
         </p:txBody>
@@ -9318,7 +9318,7 @@
                 </a:solidFill>
                 <a:latin typeface="Calibri"/>
               </a:rPr>
-              <a:t>Architecture rule we set: ledger capability never wires directly to fulfillment systems — hub is the control plane.</a:t>
+              <a:t>Architecture rule we set: Reward System never wires directly to fulfillment — hub is the control plane.</a:t>
             </a:r>
           </a:p>
         </p:txBody>
@@ -9397,9 +9397,9 @@
                 <a:latin typeface="Calibri"/>
               </a:rPr>
               <a:t>What we are proud of building
-1) A real domain split — channels / ledger / orchestration / fulfillment
+1) A real domain split — channels / Reward System / orchestration / fulfillment
 2) One controlled interface into rewards — not N brittle point-to-point links
-3) CBP and partners stay UAF assets; the ledger capability stays replaceable and focused</a:t>
+3) CBP and partners stay UAF assets; Reward System stays focused and evolvable</a:t>
             </a:r>
           </a:p>
         </p:txBody>

</xml_diff>